<commit_message>
Add reproducible experiment harness, energy model and field report; document airtime constraint
</commit_message>
<xml_diff>
--- a/forest-fire-project.pptx
+++ b/forest-fire-project.pptx
@@ -122,324 +122,6 @@
 </p:presentation>
 </file>
 
-<file path=ppt/charts/chart1.xml><?xml version="1.0" encoding="utf-8"?>
-<c:chartSpace xmlns:c="http://schemas.openxmlformats.org/drawingml/2006/chart" xmlns:a="http://schemas.openxmlformats.org/drawingml/2006/main" xmlns:r="http://schemas.openxmlformats.org/officeDocument/2006/relationships">
-  <c:date1904 val="0"/>
-  <c:roundedCorners val="1"/>
-  <c:chart>
-    <c:autoTitleDeleted val="1"/>
-    <c:plotArea>
-      <c:layout/>
-      <c:barChart>
-        <c:barDir val="bar"/>
-        <c:grouping val="clustered"/>
-        <c:varyColors val="0"/>
-        <c:ser>
-          <c:idx val="0"/>
-          <c:order val="0"/>
-          <c:tx>
-            <c:strRef>
-              <c:f>Sheet1!$B$1</c:f>
-              <c:strCache>
-                <c:ptCount val="1"/>
-                <c:pt idx="0">
-                  <c:v>Rotation ON</c:v>
-                </c:pt>
-              </c:strCache>
-            </c:strRef>
-          </c:tx>
-          <c:spPr>
-            <a:solidFill>
-              <a:srgbClr val="6FA07A"/>
-            </a:solidFill>
-            <a:effectLst/>
-          </c:spPr>
-          <c:invertIfNegative val="0"/>
-          <c:dLbls>
-            <c:numFmt formatCode="#,##0" sourceLinked="0"/>
-            <c:txPr>
-              <a:bodyPr/>
-              <a:lstStyle/>
-              <a:p>
-                <a:pPr>
-                  <a:defRPr b="0" i="0" strike="noStrike" sz="1200" u="none">
-                    <a:solidFill>
-                      <a:srgbClr val="13291C"/>
-                    </a:solidFill>
-                    <a:latin typeface="Calibri"/>
-                  </a:defRPr>
-                </a:pPr>
-              </a:p>
-            </c:txPr>
-            <c:showLegendKey val="0"/>
-            <c:showVal val="1"/>
-            <c:showCatName val="0"/>
-            <c:showSerName val="0"/>
-            <c:showPercent val="0"/>
-            <c:showBubbleSize val="0"/>
-            <c:showLeaderLines val="0"/>
-          </c:dLbls>
-          <c:cat>
-            <c:multiLvlStrRef>
-              <c:f>Sheet1!$A$2:$A$2</c:f>
-              <c:multiLvlStrCache>
-                <c:ptCount val="1"/>
-                <c:lvl>
-                  <c:pt idx="0">
-                    <c:v>First node death (round)</c:v>
-                  </c:pt>
-                </c:lvl>
-              </c:multiLvlStrCache>
-            </c:multiLvlStrRef>
-          </c:cat>
-          <c:val>
-            <c:numRef>
-              <c:f>Sheet1!$B$2:$B$2</c:f>
-              <c:numCache>
-                <c:formatCode>General</c:formatCode>
-                <c:ptCount val="1"/>
-                <c:pt idx="0">
-                  <c:v>307</c:v>
-                </c:pt>
-              </c:numCache>
-            </c:numRef>
-          </c:val>
-        </c:ser>
-        <c:ser>
-          <c:idx val="1"/>
-          <c:order val="1"/>
-          <c:tx>
-            <c:strRef>
-              <c:f>Sheet1!$C$1</c:f>
-              <c:strCache>
-                <c:ptCount val="1"/>
-                <c:pt idx="0">
-                  <c:v>Rotation OFF</c:v>
-                </c:pt>
-              </c:strCache>
-            </c:strRef>
-          </c:tx>
-          <c:spPr>
-            <a:solidFill>
-              <a:srgbClr val="C6CFC8"/>
-            </a:solidFill>
-            <a:effectLst/>
-          </c:spPr>
-          <c:invertIfNegative val="0"/>
-          <c:dLbls>
-            <c:numFmt formatCode="#,##0" sourceLinked="0"/>
-            <c:txPr>
-              <a:bodyPr/>
-              <a:lstStyle/>
-              <a:p>
-                <a:pPr>
-                  <a:defRPr b="0" i="0" strike="noStrike" sz="1200" u="none">
-                    <a:solidFill>
-                      <a:srgbClr val="13291C"/>
-                    </a:solidFill>
-                    <a:latin typeface="Calibri"/>
-                  </a:defRPr>
-                </a:pPr>
-              </a:p>
-            </c:txPr>
-            <c:showLegendKey val="0"/>
-            <c:showVal val="1"/>
-            <c:showCatName val="0"/>
-            <c:showSerName val="0"/>
-            <c:showPercent val="0"/>
-            <c:showBubbleSize val="0"/>
-            <c:showLeaderLines val="0"/>
-          </c:dLbls>
-          <c:cat>
-            <c:multiLvlStrRef>
-              <c:f>Sheet1!$A$2:$A$2</c:f>
-              <c:multiLvlStrCache>
-                <c:ptCount val="1"/>
-                <c:lvl>
-                  <c:pt idx="0">
-                    <c:v>First node death (round)</c:v>
-                  </c:pt>
-                </c:lvl>
-              </c:multiLvlStrCache>
-            </c:multiLvlStrRef>
-          </c:cat>
-          <c:val>
-            <c:numRef>
-              <c:f>Sheet1!$C$2:$C$2</c:f>
-              <c:numCache>
-                <c:formatCode>General</c:formatCode>
-                <c:ptCount val="1"/>
-                <c:pt idx="0">
-                  <c:v>212</c:v>
-                </c:pt>
-              </c:numCache>
-            </c:numRef>
-          </c:val>
-        </c:ser>
-        <c:dLbls>
-          <c:numFmt formatCode="#,##0" sourceLinked="0"/>
-          <c:txPr>
-            <a:bodyPr/>
-            <a:lstStyle/>
-            <a:p>
-              <a:pPr>
-                <a:defRPr b="0" i="0" strike="noStrike" sz="1200" u="none">
-                  <a:solidFill>
-                    <a:srgbClr val="13291C"/>
-                  </a:solidFill>
-                  <a:latin typeface="Calibri"/>
-                </a:defRPr>
-              </a:pPr>
-            </a:p>
-          </c:txPr>
-          <c:showLegendKey val="0"/>
-          <c:showVal val="1"/>
-          <c:showCatName val="0"/>
-          <c:showSerName val="0"/>
-          <c:showPercent val="0"/>
-          <c:showBubbleSize val="0"/>
-          <c:showLeaderLines val="0"/>
-        </c:dLbls>
-        <c:gapWidth val="150"/>
-        <c:overlap val="0"/>
-        <c:axId val="2094734554"/>
-        <c:axId val="2094734552"/>
-        <c:axId val="2094734556"/>
-      </c:barChart>
-      <c:catAx>
-        <c:axId val="2094734554"/>
-        <c:scaling>
-          <c:orientation val="minMax"/>
-        </c:scaling>
-        <c:delete val="0"/>
-        <c:axPos val="l"/>
-        <c:numFmt formatCode="General" sourceLinked="1"/>
-        <c:majorTickMark val="out"/>
-        <c:minorTickMark val="none"/>
-        <c:tickLblPos val="nextTo"/>
-        <c:spPr>
-          <a:ln w="12700" cap="flat">
-            <a:solidFill>
-              <a:srgbClr val="888888"/>
-            </a:solidFill>
-            <a:prstDash val="solid"/>
-            <a:round/>
-          </a:ln>
-        </c:spPr>
-        <c:txPr>
-          <a:bodyPr/>
-          <a:lstStyle/>
-          <a:p>
-            <a:pPr>
-              <a:defRPr sz="1000" b="0" i="0" u="none" strike="noStrike">
-                <a:solidFill>
-                  <a:srgbClr val="6E7D71"/>
-                </a:solidFill>
-                <a:latin typeface="Arial"/>
-              </a:defRPr>
-            </a:pPr>
-            <a:endParaRPr lang="en-US"/>
-          </a:p>
-        </c:txPr>
-        <c:crossAx val="2094734552"/>
-        <c:crosses val="autoZero"/>
-        <c:auto val="1"/>
-        <c:lblAlgn val="ctr"/>
-        <c:noMultiLvlLbl val="1"/>
-      </c:catAx>
-      <c:valAx>
-        <c:axId val="2094734552"/>
-        <c:scaling>
-          <c:orientation val="minMax"/>
-          <c:max val="350"/>
-        </c:scaling>
-        <c:delete val="0"/>
-        <c:axPos val="b"/>
-        <c:majorGridlines>
-          <c:spPr>
-            <a:ln w="12700" cap="flat">
-              <a:solidFill>
-                <a:srgbClr val="E4EAE5"/>
-              </a:solidFill>
-              <a:prstDash val="solid"/>
-              <a:round/>
-            </a:ln>
-          </c:spPr>
-        </c:majorGridlines>
-        <c:numFmt formatCode="General" sourceLinked="0"/>
-        <c:majorTickMark val="out"/>
-        <c:minorTickMark val="none"/>
-        <c:tickLblPos val="low"/>
-        <c:spPr>
-          <a:ln w="12700" cap="flat">
-            <a:solidFill>
-              <a:srgbClr val="888888"/>
-            </a:solidFill>
-            <a:prstDash val="solid"/>
-            <a:round/>
-          </a:ln>
-        </c:spPr>
-        <c:txPr>
-          <a:bodyPr/>
-          <a:lstStyle/>
-          <a:p>
-            <a:pPr>
-              <a:defRPr sz="900" b="0" i="0" u="none" strike="noStrike">
-                <a:solidFill>
-                  <a:srgbClr val="6E7D71"/>
-                </a:solidFill>
-                <a:latin typeface="Arial"/>
-              </a:defRPr>
-            </a:pPr>
-            <a:endParaRPr lang="en-US"/>
-          </a:p>
-        </c:txPr>
-        <c:crossAx val="2094734554"/>
-        <c:crosses val="autoZero"/>
-        <c:crossBetween val="between"/>
-      </c:valAx>
-      <c:spPr>
-        <a:noFill/>
-        <a:ln>
-          <a:noFill/>
-        </a:ln>
-        <a:effectLst/>
-      </c:spPr>
-    </c:plotArea>
-    <c:legend>
-      <c:legendPos val="b"/>
-      <c:overlay val="0"/>
-      <c:txPr>
-        <a:bodyPr/>
-        <a:lstStyle/>
-        <a:p>
-          <a:pPr>
-            <a:defRPr sz="1000">
-              <a:solidFill>
-                <a:srgbClr val="6E7D71"/>
-              </a:solidFill>
-            </a:defRPr>
-          </a:pPr>
-          <a:endParaRPr lang="en-US"/>
-        </a:p>
-      </c:txPr>
-    </c:legend>
-    <c:plotVisOnly val="1"/>
-    <c:dispBlanksAs val="span"/>
-  </c:chart>
-  <c:spPr>
-    <a:noFill/>
-    <a:ln>
-      <a:noFill/>
-    </a:ln>
-    <a:effectLst/>
-  </c:spPr>
-  <c:externalData r:id="rId1">
-    <c:autoUpdate val="0"/>
-  </c:externalData>
-</c:chartSpace>
-</file>
-
 <file path=ppt/notesMasters/notesMaster1.xml><?xml version="1.0" encoding="utf-8"?>
 <p:notesMaster xmlns:a="http://schemas.openxmlformats.org/drawingml/2006/main" xmlns:r="http://schemas.openxmlformats.org/officeDocument/2006/relationships" xmlns:p="http://schemas.openxmlformats.org/presentationml/2006/main">
   <p:cSld>
@@ -1011,7 +693,7 @@
           <a:p>
             <a:r>
               <a:rPr lang="en-US" dirty="0"/>
-              <a:t>Two things here. The energy model correction — a Pi is not a mote, and duty cycling is the whole story. And the rotation result, where the interesting part is what it does NOT do: total network lifetime is unchanged.</a:t>
+              <a:t>This is the strongest negative result. The radio is 1.2% of node power, so TDMA sleep — the centre of this project — is worth 4%. If asked whether that invalidates the work: no, it relocates it. The networking contribution stands; the energy claim has to be about the whole node.</a:t>
             </a:r>
             <a:endParaRPr lang="en-US" dirty="0"/>
           </a:p>
@@ -1275,7 +957,7 @@
           <a:p>
             <a:r>
               <a:rPr lang="en-US" dirty="0"/>
-              <a:t>Headline numbers. If asked about the partition case — that is correct behaviour, not a failure. CH-B can only hear CH-A and node 5, so when CH-A dies cluster B is physically cut off. Buffering is the right answer.</a:t>
+              <a:t>Headline numbers. Point at the footer: these are reproducible from the repo, not copied from a notebook. If asked about the partition case — that is correct behaviour, not a failure. CH-B can only hear CH-A and node 5, so when CH-A dies cluster B is physically cut off. Buffering is the right answer.</a:t>
             </a:r>
             <a:endParaRPr lang="en-US" dirty="0"/>
           </a:p>
@@ -4099,13 +3781,13 @@
             <a:r>
               <a:rPr lang="en-US" sz="1150" b="1" spc="220" kern="0" dirty="0">
                 <a:solidFill>
-                  <a:srgbClr val="6FA07A"/>
-                </a:solidFill>
-                <a:latin typeface="Calibri" pitchFamily="34" charset="0"/>
-                <a:ea typeface="Calibri" pitchFamily="34" charset="-122"/>
-                <a:cs typeface="Calibri" pitchFamily="34" charset="-120"/>
-              </a:rPr>
-              <a:t>ENERGY</a:t>
+                  <a:srgbClr val="E8622C"/>
+                </a:solidFill>
+                <a:latin typeface="Calibri" pitchFamily="34" charset="0"/>
+                <a:ea typeface="Calibri" pitchFamily="34" charset="-122"/>
+                <a:cs typeface="Calibri" pitchFamily="34" charset="-120"/>
+              </a:rPr>
+              <a:t>RQ5 + RQ7 — ENERGY</a:t>
             </a:r>
             <a:endParaRPr lang="en-US" sz="1150" dirty="0"/>
           </a:p>
@@ -4144,7 +3826,7 @@
                 <a:ea typeface="Cambria" pitchFamily="34" charset="-122"/>
                 <a:cs typeface="Cambria" pitchFamily="34" charset="-120"/>
               </a:rPr>
-              <a:t>The standard model was wrong for this hardware</a:t>
+              <a:t>The radio is 1% of the problem</a:t>
             </a:r>
             <a:endParaRPr lang="en-US" sz="3400" dirty="0"/>
           </a:p>
@@ -4152,18 +3834,57 @@
       </p:sp>
       <p:sp>
         <p:nvSpPr>
-          <p:cNvPr id="4" name="Shape 2"/>
-          <p:cNvSpPr/>
-          <p:nvPr/>
-        </p:nvSpPr>
-        <p:spPr>
-          <a:xfrm>
-            <a:off x="548640" y="1371600"/>
-            <a:ext cx="5394960" cy="2148840"/>
+          <p:cNvPr id="4" name="Text 2"/>
+          <p:cNvSpPr/>
+          <p:nvPr/>
+        </p:nvSpPr>
+        <p:spPr>
+          <a:xfrm>
+            <a:off x="548640" y="1280160"/>
+            <a:ext cx="10881360" cy="457200"/>
+          </a:xfrm>
+          <a:prstGeom prst="rect">
+            <a:avLst/>
+          </a:prstGeom>
+          <a:noFill/>
+          <a:ln/>
+        </p:spPr>
+        <p:txBody>
+          <a:bodyPr wrap="square" lIns="0" tIns="0" rIns="0" bIns="0" rtlCol="0" anchor="ctr"/>
+          <a:lstStyle/>
+          <a:p>
+            <a:pPr indent="0" marL="0">
+              <a:buNone/>
+            </a:pPr>
+            <a:r>
+              <a:rPr lang="en-US" sz="1400" i="1" dirty="0">
+                <a:solidFill>
+                  <a:srgbClr val="6E7D71"/>
+                </a:solidFill>
+                <a:latin typeface="Calibri" pitchFamily="34" charset="0"/>
+                <a:ea typeface="Calibri" pitchFamily="34" charset="-122"/>
+                <a:cs typeface="Calibri" pitchFamily="34" charset="-120"/>
+              </a:rPr>
+              <a:t>The standard WSN energy model accounts for the transceiver. On this hardware the transceiver is a rounding error — so every optimisation in this project acts on 1% of the budget.</a:t>
+            </a:r>
+            <a:endParaRPr lang="en-US" sz="1400" dirty="0"/>
+          </a:p>
+        </p:txBody>
+      </p:sp>
+      <p:sp>
+        <p:nvSpPr>
+          <p:cNvPr id="5" name="Shape 3"/>
+          <p:cNvSpPr/>
+          <p:nvPr/>
+        </p:nvSpPr>
+        <p:spPr>
+          <a:xfrm>
+            <a:off x="548640" y="1828800"/>
+            <a:ext cx="5394960" cy="2286000"/>
           </a:xfrm>
           <a:prstGeom prst="roundRect">
             <a:avLst>
-              <a:gd name="adj" fmla="val 3404"/>
+              <a:gd name="adj" fmla="val 3200"/>
             </a:avLst>
           </a:prstGeom>
           <a:solidFill>
@@ -4186,13 +3907,13 @@
       </p:sp>
       <p:sp>
         <p:nvSpPr>
-          <p:cNvPr id="5" name="Text 3"/>
-          <p:cNvSpPr/>
-          <p:nvPr/>
-        </p:nvSpPr>
-        <p:spPr>
-          <a:xfrm>
-            <a:off x="868680" y="1600200"/>
+          <p:cNvPr id="6" name="Text 4"/>
+          <p:cNvSpPr/>
+          <p:nvPr/>
+        </p:nvSpPr>
+        <p:spPr>
+          <a:xfrm>
+            <a:off x="868680" y="2048256"/>
             <a:ext cx="4754880" cy="320040"/>
           </a:xfrm>
           <a:prstGeom prst="rect">
@@ -4209,7 +3930,7 @@
               <a:buNone/>
             </a:pPr>
             <a:r>
-              <a:rPr lang="en-US" sz="1700" b="1" dirty="0">
+              <a:rPr lang="en-US" sz="1600" b="1" dirty="0">
                 <a:solidFill>
                   <a:srgbClr val="13291C"/>
                 </a:solidFill>
@@ -4217,37 +3938,34 @@
                 <a:ea typeface="Cambria" pitchFamily="34" charset="-122"/>
                 <a:cs typeface="Cambria" pitchFamily="34" charset="-120"/>
               </a:rPr>
-              <a:t>What went wrong</a:t>
-            </a:r>
-            <a:endParaRPr lang="en-US" sz="1700" dirty="0"/>
-          </a:p>
-        </p:txBody>
-      </p:sp>
-      <p:sp>
-        <p:nvSpPr>
-          <p:cNvPr id="6" name="Text 4"/>
-          <p:cNvSpPr/>
-          <p:nvPr/>
-        </p:nvSpPr>
-        <p:spPr>
-          <a:xfrm>
-            <a:off x="868680" y="1965960"/>
-            <a:ext cx="4754880" cy="1371600"/>
-          </a:xfrm>
-          <a:prstGeom prst="rect">
-            <a:avLst/>
-          </a:prstGeom>
-          <a:noFill/>
-          <a:ln/>
-        </p:spPr>
-        <p:txBody>
-          <a:bodyPr wrap="square" lIns="0" tIns="0" rIns="0" bIns="0" rtlCol="0" anchor="ctr"/>
-          <a:lstStyle/>
-          <a:p>
-            <a:pPr indent="0" marL="0">
-              <a:lnSpc>
-                <a:spcPts val="1700"/>
-              </a:lnSpc>
+              <a:t>Where the watts go — CH-A</a:t>
+            </a:r>
+            <a:endParaRPr lang="en-US" sz="1600" dirty="0"/>
+          </a:p>
+        </p:txBody>
+      </p:sp>
+      <p:sp>
+        <p:nvSpPr>
+          <p:cNvPr id="7" name="Text 5"/>
+          <p:cNvSpPr/>
+          <p:nvPr/>
+        </p:nvSpPr>
+        <p:spPr>
+          <a:xfrm>
+            <a:off x="868680" y="2487168"/>
+            <a:ext cx="1737360" cy="274320"/>
+          </a:xfrm>
+          <a:prstGeom prst="rect">
+            <a:avLst/>
+          </a:prstGeom>
+          <a:noFill/>
+          <a:ln/>
+        </p:spPr>
+        <p:txBody>
+          <a:bodyPr wrap="square" lIns="0" tIns="0" rIns="0" bIns="0" rtlCol="0" anchor="ctr"/>
+          <a:lstStyle/>
+          <a:p>
+            <a:pPr indent="0" marL="0">
               <a:buNone/>
             </a:pPr>
             <a:r>
@@ -4259,7 +3977,7 @@
                 <a:ea typeface="Calibri" pitchFamily="34" charset="-122"/>
                 <a:cs typeface="Calibri" pitchFamily="34" charset="-120"/>
               </a:rPr>
-              <a:t>The LEACH first-order radio model gave ZERO node deaths in 400 rounds. It was formulated for motes — microcontrollers where the radio dominates and a packet costs microjoules. Per transmission it predicted ~2.4 mJ against a 12 kJ battery: depletion would take millions of rounds.</a:t>
+              <a:t>Pi platform</a:t>
             </a:r>
             <a:endParaRPr lang="en-US" sz="1200" dirty="0"/>
           </a:p>
@@ -4267,18 +3985,379 @@
       </p:sp>
       <p:sp>
         <p:nvSpPr>
-          <p:cNvPr id="7" name="Shape 5"/>
-          <p:cNvSpPr/>
-          <p:nvPr/>
-        </p:nvSpPr>
-        <p:spPr>
-          <a:xfrm>
-            <a:off x="548640" y="3703320"/>
-            <a:ext cx="5394960" cy="2377440"/>
+          <p:cNvPr id="8" name="Shape 6"/>
+          <p:cNvSpPr/>
+          <p:nvPr/>
+        </p:nvSpPr>
+        <p:spPr>
+          <a:xfrm>
+            <a:off x="2697480" y="2551176"/>
+            <a:ext cx="2286000" cy="164592"/>
           </a:xfrm>
           <a:prstGeom prst="roundRect">
             <a:avLst>
-              <a:gd name="adj" fmla="val 3077"/>
+              <a:gd name="adj" fmla="val 22222"/>
+            </a:avLst>
+          </a:prstGeom>
+          <a:solidFill>
+            <a:srgbClr val="1E4630"/>
+          </a:solidFill>
+          <a:ln/>
+        </p:spPr>
+      </p:sp>
+      <p:sp>
+        <p:nvSpPr>
+          <p:cNvPr id="9" name="Text 7"/>
+          <p:cNvSpPr/>
+          <p:nvPr/>
+        </p:nvSpPr>
+        <p:spPr>
+          <a:xfrm>
+            <a:off x="5120640" y="2487168"/>
+            <a:ext cx="548640" cy="274320"/>
+          </a:xfrm>
+          <a:prstGeom prst="rect">
+            <a:avLst/>
+          </a:prstGeom>
+          <a:noFill/>
+          <a:ln/>
+        </p:spPr>
+        <p:txBody>
+          <a:bodyPr wrap="square" lIns="0" tIns="0" rIns="0" bIns="0" rtlCol="0" anchor="ctr"/>
+          <a:lstStyle/>
+          <a:p>
+            <a:pPr algn="r" indent="0" marL="0">
+              <a:buNone/>
+            </a:pPr>
+            <a:r>
+              <a:rPr lang="en-US" sz="1200" b="1" dirty="0">
+                <a:solidFill>
+                  <a:srgbClr val="13291C"/>
+                </a:solidFill>
+                <a:latin typeface="Calibri" pitchFamily="34" charset="0"/>
+                <a:ea typeface="Calibri" pitchFamily="34" charset="-122"/>
+                <a:cs typeface="Calibri" pitchFamily="34" charset="-120"/>
+              </a:rPr>
+              <a:t>53%</a:t>
+            </a:r>
+            <a:endParaRPr lang="en-US" sz="1200" dirty="0"/>
+          </a:p>
+        </p:txBody>
+      </p:sp>
+      <p:sp>
+        <p:nvSpPr>
+          <p:cNvPr id="10" name="Text 8"/>
+          <p:cNvSpPr/>
+          <p:nvPr/>
+        </p:nvSpPr>
+        <p:spPr>
+          <a:xfrm>
+            <a:off x="868680" y="2871216"/>
+            <a:ext cx="1737360" cy="274320"/>
+          </a:xfrm>
+          <a:prstGeom prst="rect">
+            <a:avLst/>
+          </a:prstGeom>
+          <a:noFill/>
+          <a:ln/>
+        </p:spPr>
+        <p:txBody>
+          <a:bodyPr wrap="square" lIns="0" tIns="0" rIns="0" bIns="0" rtlCol="0" anchor="ctr"/>
+          <a:lstStyle/>
+          <a:p>
+            <a:pPr indent="0" marL="0">
+              <a:buNone/>
+            </a:pPr>
+            <a:r>
+              <a:rPr lang="en-US" sz="1200" dirty="0">
+                <a:solidFill>
+                  <a:srgbClr val="6E7D71"/>
+                </a:solidFill>
+                <a:latin typeface="Calibri" pitchFamily="34" charset="0"/>
+                <a:ea typeface="Calibri" pitchFamily="34" charset="-122"/>
+                <a:cs typeface="Calibri" pitchFamily="34" charset="-120"/>
+              </a:rPr>
+              <a:t>MQ-2 heater</a:t>
+            </a:r>
+            <a:endParaRPr lang="en-US" sz="1200" dirty="0"/>
+          </a:p>
+        </p:txBody>
+      </p:sp>
+      <p:sp>
+        <p:nvSpPr>
+          <p:cNvPr id="11" name="Shape 9"/>
+          <p:cNvSpPr/>
+          <p:nvPr/>
+        </p:nvSpPr>
+        <p:spPr>
+          <a:xfrm>
+            <a:off x="2697480" y="2935224"/>
+            <a:ext cx="1958196" cy="164592"/>
+          </a:xfrm>
+          <a:prstGeom prst="roundRect">
+            <a:avLst>
+              <a:gd name="adj" fmla="val 22222"/>
+            </a:avLst>
+          </a:prstGeom>
+          <a:solidFill>
+            <a:srgbClr val="E8622C"/>
+          </a:solidFill>
+          <a:ln/>
+        </p:spPr>
+      </p:sp>
+      <p:sp>
+        <p:nvSpPr>
+          <p:cNvPr id="12" name="Text 10"/>
+          <p:cNvSpPr/>
+          <p:nvPr/>
+        </p:nvSpPr>
+        <p:spPr>
+          <a:xfrm>
+            <a:off x="5120640" y="2871216"/>
+            <a:ext cx="548640" cy="274320"/>
+          </a:xfrm>
+          <a:prstGeom prst="rect">
+            <a:avLst/>
+          </a:prstGeom>
+          <a:noFill/>
+          <a:ln/>
+        </p:spPr>
+        <p:txBody>
+          <a:bodyPr wrap="square" lIns="0" tIns="0" rIns="0" bIns="0" rtlCol="0" anchor="ctr"/>
+          <a:lstStyle/>
+          <a:p>
+            <a:pPr algn="r" indent="0" marL="0">
+              <a:buNone/>
+            </a:pPr>
+            <a:r>
+              <a:rPr lang="en-US" sz="1200" b="1" dirty="0">
+                <a:solidFill>
+                  <a:srgbClr val="13291C"/>
+                </a:solidFill>
+                <a:latin typeface="Calibri" pitchFamily="34" charset="0"/>
+                <a:ea typeface="Calibri" pitchFamily="34" charset="-122"/>
+                <a:cs typeface="Calibri" pitchFamily="34" charset="-120"/>
+              </a:rPr>
+              <a:t>45.4%</a:t>
+            </a:r>
+            <a:endParaRPr lang="en-US" sz="1200" dirty="0"/>
+          </a:p>
+        </p:txBody>
+      </p:sp>
+      <p:sp>
+        <p:nvSpPr>
+          <p:cNvPr id="13" name="Text 11"/>
+          <p:cNvSpPr/>
+          <p:nvPr/>
+        </p:nvSpPr>
+        <p:spPr>
+          <a:xfrm>
+            <a:off x="868680" y="3255264"/>
+            <a:ext cx="1737360" cy="274320"/>
+          </a:xfrm>
+          <a:prstGeom prst="rect">
+            <a:avLst/>
+          </a:prstGeom>
+          <a:noFill/>
+          <a:ln/>
+        </p:spPr>
+        <p:txBody>
+          <a:bodyPr wrap="square" lIns="0" tIns="0" rIns="0" bIns="0" rtlCol="0" anchor="ctr"/>
+          <a:lstStyle/>
+          <a:p>
+            <a:pPr indent="0" marL="0">
+              <a:buNone/>
+            </a:pPr>
+            <a:r>
+              <a:rPr lang="en-US" sz="1200" dirty="0">
+                <a:solidFill>
+                  <a:srgbClr val="6E7D71"/>
+                </a:solidFill>
+                <a:latin typeface="Calibri" pitchFamily="34" charset="0"/>
+                <a:ea typeface="Calibri" pitchFamily="34" charset="-122"/>
+                <a:cs typeface="Calibri" pitchFamily="34" charset="-120"/>
+              </a:rPr>
+              <a:t>LoRa radio</a:t>
+            </a:r>
+            <a:endParaRPr lang="en-US" sz="1200" dirty="0"/>
+          </a:p>
+        </p:txBody>
+      </p:sp>
+      <p:sp>
+        <p:nvSpPr>
+          <p:cNvPr id="14" name="Shape 12"/>
+          <p:cNvSpPr/>
+          <p:nvPr/>
+        </p:nvSpPr>
+        <p:spPr>
+          <a:xfrm>
+            <a:off x="2697480" y="3319272"/>
+            <a:ext cx="51758" cy="164592"/>
+          </a:xfrm>
+          <a:prstGeom prst="roundRect">
+            <a:avLst>
+              <a:gd name="adj" fmla="val 70667"/>
+            </a:avLst>
+          </a:prstGeom>
+          <a:solidFill>
+            <a:srgbClr val="3E7CB1"/>
+          </a:solidFill>
+          <a:ln/>
+        </p:spPr>
+      </p:sp>
+      <p:sp>
+        <p:nvSpPr>
+          <p:cNvPr id="15" name="Text 13"/>
+          <p:cNvSpPr/>
+          <p:nvPr/>
+        </p:nvSpPr>
+        <p:spPr>
+          <a:xfrm>
+            <a:off x="5120640" y="3255264"/>
+            <a:ext cx="548640" cy="274320"/>
+          </a:xfrm>
+          <a:prstGeom prst="rect">
+            <a:avLst/>
+          </a:prstGeom>
+          <a:noFill/>
+          <a:ln/>
+        </p:spPr>
+        <p:txBody>
+          <a:bodyPr wrap="square" lIns="0" tIns="0" rIns="0" bIns="0" rtlCol="0" anchor="ctr"/>
+          <a:lstStyle/>
+          <a:p>
+            <a:pPr algn="r" indent="0" marL="0">
+              <a:buNone/>
+            </a:pPr>
+            <a:r>
+              <a:rPr lang="en-US" sz="1200" b="1" dirty="0">
+                <a:solidFill>
+                  <a:srgbClr val="13291C"/>
+                </a:solidFill>
+                <a:latin typeface="Calibri" pitchFamily="34" charset="0"/>
+                <a:ea typeface="Calibri" pitchFamily="34" charset="-122"/>
+                <a:cs typeface="Calibri" pitchFamily="34" charset="-120"/>
+              </a:rPr>
+              <a:t>1.2%</a:t>
+            </a:r>
+            <a:endParaRPr lang="en-US" sz="1200" dirty="0"/>
+          </a:p>
+        </p:txBody>
+      </p:sp>
+      <p:sp>
+        <p:nvSpPr>
+          <p:cNvPr id="16" name="Text 14"/>
+          <p:cNvSpPr/>
+          <p:nvPr/>
+        </p:nvSpPr>
+        <p:spPr>
+          <a:xfrm>
+            <a:off x="868680" y="3639312"/>
+            <a:ext cx="1737360" cy="274320"/>
+          </a:xfrm>
+          <a:prstGeom prst="rect">
+            <a:avLst/>
+          </a:prstGeom>
+          <a:noFill/>
+          <a:ln/>
+        </p:spPr>
+        <p:txBody>
+          <a:bodyPr wrap="square" lIns="0" tIns="0" rIns="0" bIns="0" rtlCol="0" anchor="ctr"/>
+          <a:lstStyle/>
+          <a:p>
+            <a:pPr indent="0" marL="0">
+              <a:buNone/>
+            </a:pPr>
+            <a:r>
+              <a:rPr lang="en-US" sz="1200" dirty="0">
+                <a:solidFill>
+                  <a:srgbClr val="6E7D71"/>
+                </a:solidFill>
+                <a:latin typeface="Calibri" pitchFamily="34" charset="0"/>
+                <a:ea typeface="Calibri" pitchFamily="34" charset="-122"/>
+                <a:cs typeface="Calibri" pitchFamily="34" charset="-120"/>
+              </a:rPr>
+              <a:t>DHT22</a:t>
+            </a:r>
+            <a:endParaRPr lang="en-US" sz="1200" dirty="0"/>
+          </a:p>
+        </p:txBody>
+      </p:sp>
+      <p:sp>
+        <p:nvSpPr>
+          <p:cNvPr id="17" name="Shape 15"/>
+          <p:cNvSpPr/>
+          <p:nvPr/>
+        </p:nvSpPr>
+        <p:spPr>
+          <a:xfrm>
+            <a:off x="2697480" y="3703320"/>
+            <a:ext cx="45720" cy="164592"/>
+          </a:xfrm>
+          <a:prstGeom prst="roundRect">
+            <a:avLst>
+              <a:gd name="adj" fmla="val 80000"/>
+            </a:avLst>
+          </a:prstGeom>
+          <a:solidFill>
+            <a:srgbClr val="C6CFC8"/>
+          </a:solidFill>
+          <a:ln/>
+        </p:spPr>
+      </p:sp>
+      <p:sp>
+        <p:nvSpPr>
+          <p:cNvPr id="18" name="Text 16"/>
+          <p:cNvSpPr/>
+          <p:nvPr/>
+        </p:nvSpPr>
+        <p:spPr>
+          <a:xfrm>
+            <a:off x="5120640" y="3639312"/>
+            <a:ext cx="548640" cy="274320"/>
+          </a:xfrm>
+          <a:prstGeom prst="rect">
+            <a:avLst/>
+          </a:prstGeom>
+          <a:noFill/>
+          <a:ln/>
+        </p:spPr>
+        <p:txBody>
+          <a:bodyPr wrap="square" lIns="0" tIns="0" rIns="0" bIns="0" rtlCol="0" anchor="ctr"/>
+          <a:lstStyle/>
+          <a:p>
+            <a:pPr algn="r" indent="0" marL="0">
+              <a:buNone/>
+            </a:pPr>
+            <a:r>
+              <a:rPr lang="en-US" sz="1200" b="1" dirty="0">
+                <a:solidFill>
+                  <a:srgbClr val="13291C"/>
+                </a:solidFill>
+                <a:latin typeface="Calibri" pitchFamily="34" charset="0"/>
+                <a:ea typeface="Calibri" pitchFamily="34" charset="-122"/>
+                <a:cs typeface="Calibri" pitchFamily="34" charset="-120"/>
+              </a:rPr>
+              <a:t>0.5%</a:t>
+            </a:r>
+            <a:endParaRPr lang="en-US" sz="1200" dirty="0"/>
+          </a:p>
+        </p:txBody>
+      </p:sp>
+      <p:sp>
+        <p:nvSpPr>
+          <p:cNvPr id="19" name="Shape 17"/>
+          <p:cNvSpPr/>
+          <p:nvPr/>
+        </p:nvSpPr>
+        <p:spPr>
+          <a:xfrm>
+            <a:off x="6217920" y="1828800"/>
+            <a:ext cx="5212080" cy="2286000"/>
+          </a:xfrm>
+          <a:prstGeom prst="roundRect">
+            <a:avLst>
+              <a:gd name="adj" fmla="val 3200"/>
             </a:avLst>
           </a:prstGeom>
           <a:solidFill>
@@ -4301,30 +4380,33 @@
       </p:sp>
       <p:sp>
         <p:nvSpPr>
-          <p:cNvPr id="8" name="Text 6"/>
-          <p:cNvSpPr/>
-          <p:nvPr/>
-        </p:nvSpPr>
-        <p:spPr>
-          <a:xfrm>
-            <a:off x="868680" y="3931920"/>
-            <a:ext cx="4754880" cy="320040"/>
-          </a:xfrm>
-          <a:prstGeom prst="rect">
-            <a:avLst/>
-          </a:prstGeom>
-          <a:noFill/>
-          <a:ln/>
-        </p:spPr>
-        <p:txBody>
-          <a:bodyPr wrap="square" lIns="0" tIns="0" rIns="0" bIns="0" rtlCol="0" anchor="ctr"/>
-          <a:lstStyle/>
-          <a:p>
-            <a:pPr indent="0" marL="0">
-              <a:buNone/>
-            </a:pPr>
-            <a:r>
-              <a:rPr lang="en-US" sz="1700" b="1" dirty="0">
+          <p:cNvPr id="20" name="Text 18"/>
+          <p:cNvSpPr/>
+          <p:nvPr/>
+        </p:nvSpPr>
+        <p:spPr>
+          <a:xfrm>
+            <a:off x="6537960" y="2048256"/>
+            <a:ext cx="4572000" cy="548640"/>
+          </a:xfrm>
+          <a:prstGeom prst="rect">
+            <a:avLst/>
+          </a:prstGeom>
+          <a:noFill/>
+          <a:ln/>
+        </p:spPr>
+        <p:txBody>
+          <a:bodyPr wrap="square" lIns="0" tIns="0" rIns="0" bIns="0" rtlCol="0" anchor="ctr"/>
+          <a:lstStyle/>
+          <a:p>
+            <a:pPr indent="0" marL="0">
+              <a:lnSpc>
+                <a:spcPts val="2000"/>
+              </a:lnSpc>
+              <a:buNone/>
+            </a:pPr>
+            <a:r>
+              <a:rPr lang="en-US" sz="1600" b="1" dirty="0">
                 <a:solidFill>
                   <a:srgbClr val="FFFFFF"/>
                 </a:solidFill>
@@ -4332,22 +4414,22 @@
                 <a:ea typeface="Cambria" pitchFamily="34" charset="-122"/>
                 <a:cs typeface="Cambria" pitchFamily="34" charset="-120"/>
               </a:rPr>
-              <a:t>The correction</a:t>
-            </a:r>
-            <a:endParaRPr lang="en-US" sz="1700" dirty="0"/>
-          </a:p>
-        </p:txBody>
-      </p:sp>
-      <p:sp>
-        <p:nvSpPr>
-          <p:cNvPr id="9" name="Text 7"/>
-          <p:cNvSpPr/>
-          <p:nvPr/>
-        </p:nvSpPr>
-        <p:spPr>
-          <a:xfrm>
-            <a:off x="868680" y="4297680"/>
-            <a:ext cx="4754880" cy="777240"/>
+              <a:t>RQ5 — is the standard model valid here?</a:t>
+            </a:r>
+            <a:endParaRPr lang="en-US" sz="1600" dirty="0"/>
+          </a:p>
+        </p:txBody>
+      </p:sp>
+      <p:sp>
+        <p:nvSpPr>
+          <p:cNvPr id="21" name="Text 19"/>
+          <p:cNvSpPr/>
+          <p:nvPr/>
+        </p:nvSpPr>
+        <p:spPr>
+          <a:xfrm>
+            <a:off x="6537960" y="2606040"/>
+            <a:ext cx="4572000" cy="457200"/>
           </a:xfrm>
           <a:prstGeom prst="rect">
             <a:avLst/>
@@ -4366,7 +4448,7 @@
               <a:buNone/>
             </a:pPr>
             <a:r>
-              <a:rPr lang="en-US" sz="1200" dirty="0">
+              <a:rPr lang="en-US" sz="1250" dirty="0">
                 <a:solidFill>
                   <a:srgbClr val="9CC0A4"/>
                 </a:solidFill>
@@ -4374,123 +4456,166 @@
                 <a:ea typeface="Calibri" pitchFamily="34" charset="-122"/>
                 <a:cs typeface="Calibri" pitchFamily="34" charset="-120"/>
               </a:rPr>
-              <a:t>A Raspberry Pi 4 draws ~2.1 W awake against milliwatts of radio. The SoC dominates entirely. Adding a platform baseline term made the model behave.</a:t>
-            </a:r>
-            <a:endParaRPr lang="en-US" sz="1200" dirty="0"/>
-          </a:p>
-        </p:txBody>
-      </p:sp>
-      <p:sp>
-        <p:nvSpPr>
-          <p:cNvPr id="10" name="Text 8"/>
-          <p:cNvSpPr/>
-          <p:nvPr/>
-        </p:nvSpPr>
-        <p:spPr>
-          <a:xfrm>
-            <a:off x="868680" y="5138928"/>
-            <a:ext cx="4754880" cy="731520"/>
-          </a:xfrm>
-          <a:prstGeom prst="rect">
-            <a:avLst/>
-          </a:prstGeom>
-          <a:noFill/>
-          <a:ln/>
-        </p:spPr>
-        <p:txBody>
-          <a:bodyPr wrap="square" lIns="0" tIns="0" rIns="0" bIns="0" rtlCol="0" anchor="ctr"/>
-          <a:lstStyle/>
-          <a:p>
-            <a:pPr indent="0" marL="0">
-              <a:lnSpc>
-                <a:spcPts val="1900"/>
-              </a:lnSpc>
-              <a:buNone/>
-            </a:pPr>
-            <a:r>
-              <a:rPr lang="en-US" sz="1300" b="1" dirty="0">
+              <a:t>Applied unmodified it predicted ZERO node deaths in 400 rounds.</a:t>
+            </a:r>
+            <a:endParaRPr lang="en-US" sz="1250" dirty="0"/>
+          </a:p>
+        </p:txBody>
+      </p:sp>
+      <p:sp>
+        <p:nvSpPr>
+          <p:cNvPr id="22" name="Text 20"/>
+          <p:cNvSpPr/>
+          <p:nvPr/>
+        </p:nvSpPr>
+        <p:spPr>
+          <a:xfrm>
+            <a:off x="6537960" y="3063240"/>
+            <a:ext cx="2194560" cy="594360"/>
+          </a:xfrm>
+          <a:prstGeom prst="rect">
+            <a:avLst/>
+          </a:prstGeom>
+          <a:noFill/>
+          <a:ln/>
+        </p:spPr>
+        <p:txBody>
+          <a:bodyPr wrap="square" lIns="0" tIns="0" rIns="0" bIns="0" rtlCol="0" anchor="ctr"/>
+          <a:lstStyle/>
+          <a:p>
+            <a:pPr indent="0" marL="0">
+              <a:buNone/>
+            </a:pPr>
+            <a:r>
+              <a:rPr lang="en-US" sz="3600" b="1" dirty="0">
                 <a:solidFill>
                   <a:srgbClr val="E8622C"/>
-                </a:solidFill>
-                <a:latin typeface="Calibri" pitchFamily="34" charset="0"/>
-                <a:ea typeface="Calibri" pitchFamily="34" charset="-122"/>
-                <a:cs typeface="Calibri" pitchFamily="34" charset="-120"/>
-              </a:rPr>
-              <a:t>Battery life is set by how long a node stays AWAKE — not by transmit power or packet size.</a:t>
-            </a:r>
-            <a:endParaRPr lang="en-US" sz="1300" dirty="0"/>
-          </a:p>
-        </p:txBody>
-      </p:sp>
-      <p:sp>
-        <p:nvSpPr>
-          <p:cNvPr id="11" name="Text 9"/>
-          <p:cNvSpPr/>
-          <p:nvPr/>
-        </p:nvSpPr>
-        <p:spPr>
-          <a:xfrm>
-            <a:off x="6309360" y="1371600"/>
-            <a:ext cx="5303520" cy="365760"/>
-          </a:xfrm>
-          <a:prstGeom prst="rect">
-            <a:avLst/>
-          </a:prstGeom>
-          <a:noFill/>
-          <a:ln/>
-        </p:spPr>
-        <p:txBody>
-          <a:bodyPr wrap="square" lIns="0" tIns="0" rIns="0" bIns="0" rtlCol="0" anchor="ctr"/>
-          <a:lstStyle/>
-          <a:p>
-            <a:pPr indent="0" marL="0">
-              <a:buNone/>
-            </a:pPr>
-            <a:r>
-              <a:rPr lang="en-US" sz="1900" b="1" dirty="0">
-                <a:solidFill>
-                  <a:srgbClr val="13291C"/>
                 </a:solidFill>
                 <a:latin typeface="Cambria" pitchFamily="34" charset="0"/>
                 <a:ea typeface="Cambria" pitchFamily="34" charset="-122"/>
                 <a:cs typeface="Cambria" pitchFamily="34" charset="-120"/>
               </a:rPr>
-              <a:t>Rotating the cluster-head role</a:t>
-            </a:r>
-            <a:endParaRPr lang="en-US" sz="1900" dirty="0"/>
-          </a:p>
-        </p:txBody>
-      </p:sp>
-      <p:graphicFrame>
-        <p:nvGraphicFramePr>
-          <p:cNvPr id="12" name="Chart 0" descr=""/>
-          <p:cNvGraphicFramePr/>
-          <p:nvPr/>
-        </p:nvGraphicFramePr>
-        <p:xfrm>
-          <a:off x="6309360" y="1783080"/>
-          <a:ext cx="5303520" cy="1828800"/>
-        </p:xfrm>
-        <a:graphic xmlns:a="http://schemas.openxmlformats.org/drawingml/2006/main">
-          <a:graphicData uri="http://schemas.openxmlformats.org/drawingml/2006/chart">
-            <c:chart xmlns:c="http://schemas.openxmlformats.org/drawingml/2006/chart" r:id="rId1"/>
-          </a:graphicData>
-        </a:graphic>
-      </p:graphicFrame>
-      <p:sp>
-        <p:nvSpPr>
-          <p:cNvPr id="13" name="Shape 10"/>
-          <p:cNvSpPr/>
-          <p:nvPr/>
-        </p:nvSpPr>
-        <p:spPr>
-          <a:xfrm>
-            <a:off x="6309360" y="3840480"/>
-            <a:ext cx="5303520" cy="2240280"/>
+              <a:t>1450x</a:t>
+            </a:r>
+            <a:endParaRPr lang="en-US" sz="3600" dirty="0"/>
+          </a:p>
+        </p:txBody>
+      </p:sp>
+      <p:sp>
+        <p:nvSpPr>
+          <p:cNvPr id="23" name="Text 21"/>
+          <p:cNvSpPr/>
+          <p:nvPr/>
+        </p:nvSpPr>
+        <p:spPr>
+          <a:xfrm>
+            <a:off x="8778240" y="3154680"/>
+            <a:ext cx="2377440" cy="548640"/>
+          </a:xfrm>
+          <a:prstGeom prst="rect">
+            <a:avLst/>
+          </a:prstGeom>
+          <a:noFill/>
+          <a:ln/>
+        </p:spPr>
+        <p:txBody>
+          <a:bodyPr wrap="square" lIns="0" tIns="0" rIns="0" bIns="0" rtlCol="0" anchor="ctr"/>
+          <a:lstStyle/>
+          <a:p>
+            <a:pPr indent="0" marL="0">
+              <a:lnSpc>
+                <a:spcPts val="1500"/>
+              </a:lnSpc>
+              <a:buNone/>
+            </a:pPr>
+            <a:r>
+              <a:rPr lang="en-US" sz="1150" dirty="0">
+                <a:solidFill>
+                  <a:srgbClr val="9CC0A4"/>
+                </a:solidFill>
+                <a:latin typeface="Calibri" pitchFamily="34" charset="0"/>
+                <a:ea typeface="Calibri" pitchFamily="34" charset="-122"/>
+                <a:cs typeface="Calibri" pitchFamily="34" charset="-120"/>
+              </a:rPr>
+              <a:t>overstatement of</a:t>
+            </a:r>
+            <a:endParaRPr lang="en-US" sz="1150" dirty="0"/>
+          </a:p>
+          <a:p>
+            <a:pPr indent="0" marL="0">
+              <a:lnSpc>
+                <a:spcPts val="1500"/>
+              </a:lnSpc>
+              <a:buNone/>
+            </a:pPr>
+            <a:r>
+              <a:rPr lang="en-US" sz="1150" dirty="0">
+                <a:solidFill>
+                  <a:srgbClr val="9CC0A4"/>
+                </a:solidFill>
+                <a:latin typeface="Calibri" pitchFamily="34" charset="0"/>
+                <a:ea typeface="Calibri" pitchFamily="34" charset="-122"/>
+                <a:cs typeface="Calibri" pitchFamily="34" charset="-120"/>
+              </a:rPr>
+              <a:t>battery life</a:t>
+            </a:r>
+            <a:endParaRPr lang="en-US" sz="1150" dirty="0"/>
+          </a:p>
+        </p:txBody>
+      </p:sp>
+      <p:sp>
+        <p:nvSpPr>
+          <p:cNvPr id="24" name="Text 22"/>
+          <p:cNvSpPr/>
+          <p:nvPr/>
+        </p:nvSpPr>
+        <p:spPr>
+          <a:xfrm>
+            <a:off x="6537960" y="3730752"/>
+            <a:ext cx="4572000" cy="274320"/>
+          </a:xfrm>
+          <a:prstGeom prst="rect">
+            <a:avLst/>
+          </a:prstGeom>
+          <a:noFill/>
+          <a:ln/>
+        </p:spPr>
+        <p:txBody>
+          <a:bodyPr wrap="square" lIns="0" tIns="0" rIns="0" bIns="0" rtlCol="0" anchor="ctr"/>
+          <a:lstStyle/>
+          <a:p>
+            <a:pPr indent="0" marL="0">
+              <a:buNone/>
+            </a:pPr>
+            <a:r>
+              <a:rPr lang="en-US" sz="1200" b="1" dirty="0">
+                <a:solidFill>
+                  <a:srgbClr val="FFFFFF"/>
+                </a:solidFill>
+                <a:latin typeface="Calibri" pitchFamily="34" charset="0"/>
+                <a:ea typeface="Calibri" pitchFamily="34" charset="-122"/>
+                <a:cs typeface="Calibri" pitchFamily="34" charset="-120"/>
+              </a:rPr>
+              <a:t>Answer: no. A Pi is not a mote.</a:t>
+            </a:r>
+            <a:endParaRPr lang="en-US" sz="1200" dirty="0"/>
+          </a:p>
+        </p:txBody>
+      </p:sp>
+      <p:sp>
+        <p:nvSpPr>
+          <p:cNvPr id="25" name="Shape 23"/>
+          <p:cNvSpPr/>
+          <p:nvPr/>
+        </p:nvSpPr>
+        <p:spPr>
+          <a:xfrm>
+            <a:off x="548640" y="4343400"/>
+            <a:ext cx="10881360" cy="1783080"/>
           </a:xfrm>
           <a:prstGeom prst="roundRect">
             <a:avLst>
-              <a:gd name="adj" fmla="val 3265"/>
+              <a:gd name="adj" fmla="val 4103"/>
             </a:avLst>
           </a:prstGeom>
           <a:solidFill>
@@ -4513,68 +4638,65 @@
       </p:sp>
       <p:sp>
         <p:nvSpPr>
-          <p:cNvPr id="14" name="Text 11"/>
-          <p:cNvSpPr/>
-          <p:nvPr/>
-        </p:nvSpPr>
-        <p:spPr>
-          <a:xfrm>
-            <a:off x="6629400" y="4069080"/>
-            <a:ext cx="4663440" cy="365760"/>
-          </a:xfrm>
-          <a:prstGeom prst="rect">
-            <a:avLst/>
-          </a:prstGeom>
-          <a:noFill/>
-          <a:ln/>
-        </p:spPr>
-        <p:txBody>
-          <a:bodyPr wrap="square" lIns="0" tIns="0" rIns="0" bIns="0" rtlCol="0" anchor="ctr"/>
-          <a:lstStyle/>
-          <a:p>
-            <a:pPr indent="0" marL="0">
-              <a:buNone/>
-            </a:pPr>
-            <a:r>
-              <a:rPr lang="en-US" sz="1400" b="1" dirty="0">
+          <p:cNvPr id="26" name="Text 24"/>
+          <p:cNvSpPr/>
+          <p:nvPr/>
+        </p:nvSpPr>
+        <p:spPr>
+          <a:xfrm>
+            <a:off x="868680" y="4553712"/>
+            <a:ext cx="5486400" cy="320040"/>
+          </a:xfrm>
+          <a:prstGeom prst="rect">
+            <a:avLst/>
+          </a:prstGeom>
+          <a:noFill/>
+          <a:ln/>
+        </p:spPr>
+        <p:txBody>
+          <a:bodyPr wrap="square" lIns="0" tIns="0" rIns="0" bIns="0" rtlCol="0" anchor="ctr"/>
+          <a:lstStyle/>
+          <a:p>
+            <a:pPr indent="0" marL="0">
+              <a:buNone/>
+            </a:pPr>
+            <a:r>
+              <a:rPr lang="en-US" sz="1600" b="1" dirty="0">
                 <a:solidFill>
                   <a:srgbClr val="13291C"/>
                 </a:solidFill>
-                <a:latin typeface="Calibri" pitchFamily="34" charset="0"/>
-                <a:ea typeface="Calibri" pitchFamily="34" charset="-122"/>
-                <a:cs typeface="Calibri" pitchFamily="34" charset="-120"/>
-              </a:rPr>
-              <a:t>Rotation delays the first death by 45%</a:t>
-            </a:r>
-            <a:endParaRPr lang="en-US" sz="1400" dirty="0"/>
-          </a:p>
-        </p:txBody>
-      </p:sp>
-      <p:sp>
-        <p:nvSpPr>
-          <p:cNvPr id="15" name="Text 12"/>
-          <p:cNvSpPr/>
-          <p:nvPr/>
-        </p:nvSpPr>
-        <p:spPr>
-          <a:xfrm>
-            <a:off x="6629400" y="4480560"/>
-            <a:ext cx="4663440" cy="1463040"/>
-          </a:xfrm>
-          <a:prstGeom prst="rect">
-            <a:avLst/>
-          </a:prstGeom>
-          <a:noFill/>
-          <a:ln/>
-        </p:spPr>
-        <p:txBody>
-          <a:bodyPr wrap="square" lIns="0" tIns="0" rIns="0" bIns="0" rtlCol="0" anchor="ctr"/>
-          <a:lstStyle/>
-          <a:p>
-            <a:pPr indent="0" marL="0">
-              <a:lnSpc>
-                <a:spcPts val="1600"/>
-              </a:lnSpc>
+                <a:latin typeface="Cambria" pitchFamily="34" charset="0"/>
+                <a:ea typeface="Cambria" pitchFamily="34" charset="-122"/>
+                <a:cs typeface="Cambria" pitchFamily="34" charset="-120"/>
+              </a:rPr>
+              <a:t>RQ7 — is battery operation viable?</a:t>
+            </a:r>
+            <a:endParaRPr lang="en-US" sz="1600" dirty="0"/>
+          </a:p>
+        </p:txBody>
+      </p:sp>
+      <p:sp>
+        <p:nvSpPr>
+          <p:cNvPr id="27" name="Text 25"/>
+          <p:cNvSpPr/>
+          <p:nvPr/>
+        </p:nvSpPr>
+        <p:spPr>
+          <a:xfrm>
+            <a:off x="868680" y="4983480"/>
+            <a:ext cx="2468880" cy="274320"/>
+          </a:xfrm>
+          <a:prstGeom prst="rect">
+            <a:avLst/>
+          </a:prstGeom>
+          <a:noFill/>
+          <a:ln/>
+        </p:spPr>
+        <p:txBody>
+          <a:bodyPr wrap="square" lIns="0" tIns="0" rIns="0" bIns="0" rtlCol="0" anchor="ctr"/>
+          <a:lstStyle/>
+          <a:p>
+            <a:pPr indent="0" marL="0">
               <a:buNone/>
             </a:pPr>
             <a:r>
@@ -4586,24 +4708,151 @@
                 <a:ea typeface="Calibri" pitchFamily="34" charset="-122"/>
                 <a:cs typeface="Calibri" pitchFamily="34" charset="-120"/>
               </a:rPr>
-              <a:t>Head-duty spread also falls sharply — σ 28.4 with rotation against 72.6 without.</a:t>
+              <a:t>As built</a:t>
             </a:r>
             <a:endParaRPr lang="en-US" sz="1150" dirty="0"/>
           </a:p>
-          <a:p>
-            <a:pPr indent="0" marL="0">
-              <a:lnSpc>
-                <a:spcPts val="1600"/>
-              </a:lnSpc>
-              <a:buNone/>
-            </a:pPr>
+        </p:txBody>
+      </p:sp>
+      <p:sp>
+        <p:nvSpPr>
+          <p:cNvPr id="28" name="Text 26"/>
+          <p:cNvSpPr/>
+          <p:nvPr/>
+        </p:nvSpPr>
+        <p:spPr>
+          <a:xfrm>
+            <a:off x="868680" y="5230368"/>
+            <a:ext cx="2468880" cy="411480"/>
+          </a:xfrm>
+          <a:prstGeom prst="rect">
+            <a:avLst/>
+          </a:prstGeom>
+          <a:noFill/>
+          <a:ln/>
+        </p:spPr>
+        <p:txBody>
+          <a:bodyPr wrap="square" lIns="0" tIns="0" rIns="0" bIns="0" rtlCol="0" anchor="ctr"/>
+          <a:lstStyle/>
+          <a:p>
+            <a:pPr indent="0" marL="0">
+              <a:buNone/>
+            </a:pPr>
+            <a:r>
+              <a:rPr lang="en-US" sz="2400" b="1" dirty="0">
+                <a:solidFill>
+                  <a:srgbClr val="C1352B"/>
+                </a:solidFill>
+                <a:latin typeface="Cambria" pitchFamily="34" charset="0"/>
+                <a:ea typeface="Cambria" pitchFamily="34" charset="-122"/>
+                <a:cs typeface="Cambria" pitchFamily="34" charset="-120"/>
+              </a:rPr>
+              <a:t>2.7 h</a:t>
+            </a:r>
+            <a:endParaRPr lang="en-US" sz="2400" dirty="0"/>
+          </a:p>
+        </p:txBody>
+      </p:sp>
+      <p:sp>
+        <p:nvSpPr>
+          <p:cNvPr id="29" name="Text 27"/>
+          <p:cNvSpPr/>
+          <p:nvPr/>
+        </p:nvSpPr>
+        <p:spPr>
+          <a:xfrm>
+            <a:off x="3566160" y="4983480"/>
+            <a:ext cx="2468880" cy="274320"/>
+          </a:xfrm>
+          <a:prstGeom prst="rect">
+            <a:avLst/>
+          </a:prstGeom>
+          <a:noFill/>
+          <a:ln/>
+        </p:spPr>
+        <p:txBody>
+          <a:bodyPr wrap="square" lIns="0" tIns="0" rIns="0" bIns="0" rtlCol="0" anchor="ctr"/>
+          <a:lstStyle/>
+          <a:p>
+            <a:pPr indent="0" marL="0">
+              <a:buNone/>
+            </a:pPr>
+            <a:r>
+              <a:rPr lang="en-US" sz="1150" dirty="0">
+                <a:solidFill>
+                  <a:srgbClr val="6E7D71"/>
+                </a:solidFill>
+                <a:latin typeface="Calibri" pitchFamily="34" charset="0"/>
+                <a:ea typeface="Calibri" pitchFamily="34" charset="-122"/>
+                <a:cs typeface="Calibri" pitchFamily="34" charset="-120"/>
+              </a:rPr>
+              <a:t>Radio sleep OFF</a:t>
+            </a:r>
             <a:endParaRPr lang="en-US" sz="1150" dirty="0"/>
           </a:p>
-          <a:p>
-            <a:pPr indent="0" marL="0">
-              <a:lnSpc>
-                <a:spcPts val="1600"/>
-              </a:lnSpc>
+        </p:txBody>
+      </p:sp>
+      <p:sp>
+        <p:nvSpPr>
+          <p:cNvPr id="30" name="Text 28"/>
+          <p:cNvSpPr/>
+          <p:nvPr/>
+        </p:nvSpPr>
+        <p:spPr>
+          <a:xfrm>
+            <a:off x="3566160" y="5230368"/>
+            <a:ext cx="2468880" cy="411480"/>
+          </a:xfrm>
+          <a:prstGeom prst="rect">
+            <a:avLst/>
+          </a:prstGeom>
+          <a:noFill/>
+          <a:ln/>
+        </p:spPr>
+        <p:txBody>
+          <a:bodyPr wrap="square" lIns="0" tIns="0" rIns="0" bIns="0" rtlCol="0" anchor="ctr"/>
+          <a:lstStyle/>
+          <a:p>
+            <a:pPr indent="0" marL="0">
+              <a:buNone/>
+            </a:pPr>
+            <a:r>
+              <a:rPr lang="en-US" sz="2400" b="1" dirty="0">
+                <a:solidFill>
+                  <a:srgbClr val="C1352B"/>
+                </a:solidFill>
+                <a:latin typeface="Cambria" pitchFamily="34" charset="0"/>
+                <a:ea typeface="Cambria" pitchFamily="34" charset="-122"/>
+                <a:cs typeface="Cambria" pitchFamily="34" charset="-120"/>
+              </a:rPr>
+              <a:t>2.6 h</a:t>
+            </a:r>
+            <a:endParaRPr lang="en-US" sz="2400" dirty="0"/>
+          </a:p>
+        </p:txBody>
+      </p:sp>
+      <p:sp>
+        <p:nvSpPr>
+          <p:cNvPr id="31" name="Text 29"/>
+          <p:cNvSpPr/>
+          <p:nvPr/>
+        </p:nvSpPr>
+        <p:spPr>
+          <a:xfrm>
+            <a:off x="6263640" y="4983480"/>
+            <a:ext cx="2468880" cy="274320"/>
+          </a:xfrm>
+          <a:prstGeom prst="rect">
+            <a:avLst/>
+          </a:prstGeom>
+          <a:noFill/>
+          <a:ln/>
+        </p:spPr>
+        <p:txBody>
+          <a:bodyPr wrap="square" lIns="0" tIns="0" rIns="0" bIns="0" rtlCol="0" anchor="ctr"/>
+          <a:lstStyle/>
+          <a:p>
+            <a:pPr indent="0" marL="0">
               <a:buNone/>
             </a:pPr>
             <a:r>
@@ -4615,7 +4864,163 @@
                 <a:ea typeface="Calibri" pitchFamily="34" charset="-122"/>
                 <a:cs typeface="Calibri" pitchFamily="34" charset="-120"/>
               </a:rPr>
-              <a:t>But half-network death barely moves: round 317 versus 320. Rotation EQUALISES node lifetime rather than extending total network life — which is precisely its purpose, and a more informative result than a uniform improvement would have been.</a:t>
+              <a:t>No MQ-2</a:t>
+            </a:r>
+            <a:endParaRPr lang="en-US" sz="1150" dirty="0"/>
+          </a:p>
+        </p:txBody>
+      </p:sp>
+      <p:sp>
+        <p:nvSpPr>
+          <p:cNvPr id="32" name="Text 30"/>
+          <p:cNvSpPr/>
+          <p:nvPr/>
+        </p:nvSpPr>
+        <p:spPr>
+          <a:xfrm>
+            <a:off x="6263640" y="5230368"/>
+            <a:ext cx="2468880" cy="411480"/>
+          </a:xfrm>
+          <a:prstGeom prst="rect">
+            <a:avLst/>
+          </a:prstGeom>
+          <a:noFill/>
+          <a:ln/>
+        </p:spPr>
+        <p:txBody>
+          <a:bodyPr wrap="square" lIns="0" tIns="0" rIns="0" bIns="0" rtlCol="0" anchor="ctr"/>
+          <a:lstStyle/>
+          <a:p>
+            <a:pPr indent="0" marL="0">
+              <a:buNone/>
+            </a:pPr>
+            <a:r>
+              <a:rPr lang="en-US" sz="2400" b="1" dirty="0">
+                <a:solidFill>
+                  <a:srgbClr val="6FA07A"/>
+                </a:solidFill>
+                <a:latin typeface="Cambria" pitchFamily="34" charset="0"/>
+                <a:ea typeface="Cambria" pitchFamily="34" charset="-122"/>
+                <a:cs typeface="Cambria" pitchFamily="34" charset="-120"/>
+              </a:rPr>
+              <a:t>7.0 h</a:t>
+            </a:r>
+            <a:endParaRPr lang="en-US" sz="2400" dirty="0"/>
+          </a:p>
+        </p:txBody>
+      </p:sp>
+      <p:sp>
+        <p:nvSpPr>
+          <p:cNvPr id="33" name="Text 31"/>
+          <p:cNvSpPr/>
+          <p:nvPr/>
+        </p:nvSpPr>
+        <p:spPr>
+          <a:xfrm>
+            <a:off x="8961120" y="4983480"/>
+            <a:ext cx="2468880" cy="274320"/>
+          </a:xfrm>
+          <a:prstGeom prst="rect">
+            <a:avLst/>
+          </a:prstGeom>
+          <a:noFill/>
+          <a:ln/>
+        </p:spPr>
+        <p:txBody>
+          <a:bodyPr wrap="square" lIns="0" tIns="0" rIns="0" bIns="0" rtlCol="0" anchor="ctr"/>
+          <a:lstStyle/>
+          <a:p>
+            <a:pPr indent="0" marL="0">
+              <a:buNone/>
+            </a:pPr>
+            <a:r>
+              <a:rPr lang="en-US" sz="1150" dirty="0">
+                <a:solidFill>
+                  <a:srgbClr val="6E7D71"/>
+                </a:solidFill>
+                <a:latin typeface="Calibri" pitchFamily="34" charset="0"/>
+                <a:ea typeface="Calibri" pitchFamily="34" charset="-122"/>
+                <a:cs typeface="Calibri" pitchFamily="34" charset="-120"/>
+              </a:rPr>
+              <a:t>MCU + no MQ-2</a:t>
+            </a:r>
+            <a:endParaRPr lang="en-US" sz="1150" dirty="0"/>
+          </a:p>
+        </p:txBody>
+      </p:sp>
+      <p:sp>
+        <p:nvSpPr>
+          <p:cNvPr id="34" name="Text 32"/>
+          <p:cNvSpPr/>
+          <p:nvPr/>
+        </p:nvSpPr>
+        <p:spPr>
+          <a:xfrm>
+            <a:off x="8961120" y="5230368"/>
+            <a:ext cx="2468880" cy="411480"/>
+          </a:xfrm>
+          <a:prstGeom prst="rect">
+            <a:avLst/>
+          </a:prstGeom>
+          <a:noFill/>
+          <a:ln/>
+        </p:spPr>
+        <p:txBody>
+          <a:bodyPr wrap="square" lIns="0" tIns="0" rIns="0" bIns="0" rtlCol="0" anchor="ctr"/>
+          <a:lstStyle/>
+          <a:p>
+            <a:pPr indent="0" marL="0">
+              <a:buNone/>
+            </a:pPr>
+            <a:r>
+              <a:rPr lang="en-US" sz="2400" b="1" dirty="0">
+                <a:solidFill>
+                  <a:srgbClr val="6FA07A"/>
+                </a:solidFill>
+                <a:latin typeface="Cambria" pitchFamily="34" charset="0"/>
+                <a:ea typeface="Cambria" pitchFamily="34" charset="-122"/>
+                <a:cs typeface="Cambria" pitchFamily="34" charset="-120"/>
+              </a:rPr>
+              <a:t>21.8 h</a:t>
+            </a:r>
+            <a:endParaRPr lang="en-US" sz="2400" dirty="0"/>
+          </a:p>
+        </p:txBody>
+      </p:sp>
+      <p:sp>
+        <p:nvSpPr>
+          <p:cNvPr id="35" name="Text 33"/>
+          <p:cNvSpPr/>
+          <p:nvPr/>
+        </p:nvSpPr>
+        <p:spPr>
+          <a:xfrm>
+            <a:off x="868680" y="5687568"/>
+            <a:ext cx="10241280" cy="365760"/>
+          </a:xfrm>
+          <a:prstGeom prst="rect">
+            <a:avLst/>
+          </a:prstGeom>
+          <a:noFill/>
+          <a:ln/>
+        </p:spPr>
+        <p:txBody>
+          <a:bodyPr wrap="square" lIns="0" tIns="0" rIns="0" bIns="0" rtlCol="0" anchor="ctr"/>
+          <a:lstStyle/>
+          <a:p>
+            <a:pPr indent="0" marL="0">
+              <a:buNone/>
+            </a:pPr>
+            <a:r>
+              <a:rPr lang="en-US" sz="1150" i="1" dirty="0">
+                <a:solidFill>
+                  <a:srgbClr val="6E7D71"/>
+                </a:solidFill>
+                <a:latin typeface="Calibri" pitchFamily="34" charset="0"/>
+                <a:ea typeface="Calibri" pitchFamily="34" charset="-122"/>
+                <a:cs typeface="Calibri" pitchFamily="34" charset="-120"/>
+              </a:rPr>
+              <a:t>Disabling the radio sleep — the mechanism this project is built around — costs 4%. Removing the gas sensor is worth 3x. NOT viable as built, and the blocker is not the network.</a:t>
             </a:r>
             <a:endParaRPr lang="en-US" sz="1150" dirty="0"/>
           </a:p>
@@ -8320,6 +8725,45 @@
                 <a:cs typeface="Calibri" pitchFamily="34" charset="-120"/>
               </a:rPr>
               <a:t>Cluster B correctly partitioned and buffered — no algorithm can cross a physical partition</a:t>
+            </a:r>
+            <a:endParaRPr lang="en-US" sz="1100" dirty="0"/>
+          </a:p>
+        </p:txBody>
+      </p:sp>
+      <p:sp>
+        <p:nvSpPr>
+          <p:cNvPr id="45" name="Text 43"/>
+          <p:cNvSpPr/>
+          <p:nvPr/>
+        </p:nvSpPr>
+        <p:spPr>
+          <a:xfrm>
+            <a:off x="640080" y="6263640"/>
+            <a:ext cx="10881360" cy="320040"/>
+          </a:xfrm>
+          <a:prstGeom prst="rect">
+            <a:avLst/>
+          </a:prstGeom>
+          <a:noFill/>
+          <a:ln/>
+        </p:spPr>
+        <p:txBody>
+          <a:bodyPr wrap="square" lIns="0" tIns="0" rIns="0" bIns="0" rtlCol="0" anchor="ctr"/>
+          <a:lstStyle/>
+          <a:p>
+            <a:pPr algn="ctr" indent="0" marL="0">
+              <a:buNone/>
+            </a:pPr>
+            <a:r>
+              <a:rPr lang="en-US" sz="1100" i="1" dirty="0">
+                <a:solidFill>
+                  <a:srgbClr val="6FA07A"/>
+                </a:solidFill>
+                <a:latin typeface="Calibri" pitchFamily="34" charset="0"/>
+                <a:ea typeface="Calibri" pitchFamily="34" charset="-122"/>
+                <a:cs typeface="Calibri" pitchFamily="34" charset="-120"/>
+              </a:rPr>
+              <a:t>Every figure regenerated by  python3 pi/tools/experiments.py</a:t>
             </a:r>
             <a:endParaRPr lang="en-US" sz="1100" dirty="0"/>
           </a:p>

</xml_diff>